<commit_message>
Add public evaluator links and QR codes to prototype evidence
</commit_message>
<xml_diff>
--- a/pitch-deck/HERE_Prototype_Proofs_EN.pptx
+++ b/pitch-deck/HERE_Prototype_Proofs_EN.pptx
@@ -4758,7 +4758,7 @@
         <p:spPr>
           <a:xfrm>
             <a:off x="8096250" y="5172075"/>
-            <a:ext cx="3524250" cy="800100"/>
+            <a:ext cx="2381250" cy="800100"/>
           </a:xfrm>
           <a:prstGeom prst="rect">
             <a:avLst/>
@@ -4803,8 +4803,9 @@
                 <a:latin typeface="Segoe UI"/>
                 <a:ea typeface="Segoe UI"/>
                 <a:cs typeface="Segoe UI"/>
+                <a:hlinkClick r:id="rIdHereRepository"/>
               </a:rPr>
-              <a:t>Included with a sample map</a:t>
+              <a:t>GitHub: Kugel-M/Here</a:t>
             </a:r>
           </a:p>
           <a:p>
@@ -4826,8 +4827,9 @@
                 <a:latin typeface="Segoe UI"/>
                 <a:ea typeface="Segoe UI"/>
                 <a:cs typeface="Segoe UI"/>
+                <a:hlinkClick r:id="rIdHereRepository"/>
               </a:rPr>
-              <a:t>in the handover package.</a:t>
+              <a:t>Source, video and map</a:t>
             </a:r>
           </a:p>
         </p:txBody>
@@ -4968,6 +4970,28 @@
           </a:p>
         </p:txBody>
       </p:sp>
+      <p:pic>
+        <p:nvPicPr>
+          <p:cNvPr id="14" name="Repository QR" descr="https://github.com/Kugel-M/Here"/>
+          <p:cNvPicPr/>
+          <p:nvPr/>
+        </p:nvPicPr>
+        <p:blipFill>
+          <a:blip r:embed="rIdHereRepositoryQR"/>
+          <a:stretch>
+            <a:fillRect/>
+          </a:stretch>
+        </p:blipFill>
+        <p:spPr>
+          <a:xfrm>
+            <a:off x="10706100" y="5162550"/>
+            <a:ext cx="876300" cy="876300"/>
+          </a:xfrm>
+          <a:prstGeom prst="rect">
+            <a:avLst/>
+          </a:prstGeom>
+        </p:spPr>
+      </p:pic>
     </p:spTree>
     <p:extLst>
       <p:ext uri="{BB962C8B-B14F-4D97-AF65-F5344CB8AC3E}">

</xml_diff>